<commit_message>
docs: update project presentation
Co-Authored-By: Claude Opus 5.5 <noreply@anthropic.com>
</commit_message>
<xml_diff>
--- a/Docs/GalaxyVentas-presentacion.pptx
+++ b/Docs/GalaxyVentas-presentacion.pptx
@@ -1847,7 +1847,62 @@
                   <a:schemeClr val="bg1"/>
                 </a:solidFill>
               </a:rPr>
-              <a:t>ASP.NET Core MVC · .NET 10 · Clean Architecture  |  Octubre 2026</a:t>
+              <a:t>ASP.NET Core MVC · .NET 10 · Clean Architecture  |  </a:t>
+            </a:r>
+            <a:r>
+              <a:rPr lang="en-US" sz="1600" dirty="0" err="1">
+                <a:solidFill>
+                  <a:schemeClr val="bg1"/>
+                </a:solidFill>
+              </a:rPr>
+              <a:t>Octubre</a:t>
+            </a:r>
+            <a:r>
+              <a:rPr lang="en-US" sz="1600" dirty="0">
+                <a:solidFill>
+                  <a:schemeClr val="bg1"/>
+                </a:solidFill>
+              </a:rPr>
+              <a:t> </a:t>
+            </a:r>
+            <a:r>
+              <a:rPr lang="en-US" sz="1600" dirty="0" smtClean="0">
+                <a:solidFill>
+                  <a:schemeClr val="bg1"/>
+                </a:solidFill>
+              </a:rPr>
+              <a:t>2026</a:t>
+            </a:r>
+          </a:p>
+          <a:p>
+            <a:pPr marL="0" indent="0">
+              <a:buNone/>
+            </a:pPr>
+            <a:endParaRPr lang="en-US" sz="1600" dirty="0">
+              <a:solidFill>
+                <a:schemeClr val="bg1"/>
+              </a:solidFill>
+            </a:endParaRPr>
+          </a:p>
+          <a:p>
+            <a:pPr marL="0" indent="0">
+              <a:buNone/>
+            </a:pPr>
+            <a:r>
+              <a:rPr lang="en-US" sz="1600" dirty="0" err="1" smtClean="0">
+                <a:solidFill>
+                  <a:schemeClr val="bg1"/>
+                </a:solidFill>
+              </a:rPr>
+              <a:t>Nombre</a:t>
+            </a:r>
+            <a:r>
+              <a:rPr lang="en-US" sz="1600" dirty="0" smtClean="0">
+                <a:solidFill>
+                  <a:schemeClr val="bg1"/>
+                </a:solidFill>
+              </a:rPr>
+              <a:t> :  Juan Elio Lujan Ayquipa</a:t>
             </a:r>
             <a:endParaRPr lang="en-US" sz="1600" dirty="0"/>
           </a:p>

</xml_diff>